<commit_message>
feat: redesign presentation to clean white stickman fintech theme with stickman illustrations
- Switch entire presentation deck to clean white background with crisp charcoal typography
- Replace photo-realistic images with charming stickman fintech animated illustrations
- Update interactive presentation HTML, 23 spotlight states, and AVFoundation video
- Regenerate native 10-slide PowerPoint pitch deck (PPTX) and widescreen PDF
- Maintain exact voiceover synchronization and 142.8s total duration (< 2m 30s rule)
</commit_message>
<xml_diff>
--- a/FinFlow_Pitch_Deck.pptx
+++ b/FinFlow_Pitch_Deck.pptx
@@ -3112,7 +3112,7 @@
             <a:avLst/>
           </a:prstGeom>
           <a:solidFill>
-            <a:srgbClr val="0B0F17"/>
+            <a:srgbClr val="FFFFFF"/>
           </a:solidFill>
           <a:ln>
             <a:noFill/>
@@ -3165,12 +3165,12 @@
             <a:pPr>
               <a:defRPr sz="1100" b="1">
                 <a:solidFill>
-                  <a:srgbClr val="10B981"/>
-                </a:solidFill>
-              </a:defRPr>
-            </a:pPr>
-            <a:r>
-              <a:t>FINTECH &amp; SOCIAL IMPACT • GRAPHIQUES INNOVATION CHALLENGE</a:t>
+                  <a:srgbClr val="059669"/>
+                </a:solidFill>
+              </a:defRPr>
+            </a:pPr>
+            <a:r>
+              <a:t>₹ FINFLOW (VYAPARSETU)  •  GRAPHIQUES INNOVATION CHALLENGE</a:t>
             </a:r>
           </a:p>
         </p:txBody>
@@ -3200,12 +3200,12 @@
             <a:pPr>
               <a:defRPr sz="2800" b="1">
                 <a:solidFill>
-                  <a:srgbClr val="FFFFFF"/>
-                </a:solidFill>
-              </a:defRPr>
-            </a:pPr>
-            <a:r>
-              <a:t>FinFlow (VyaparSetu): Algorithmic Daily Capital &amp; Climate Resilience</a:t>
+                  <a:srgbClr val="0F172A"/>
+                </a:solidFill>
+              </a:defRPr>
+            </a:pPr>
+            <a:r>
+              <a:t>FinFlow: Algorithmic Daily Capital &amp; Parametric Climate Resilience</a:t>
             </a:r>
           </a:p>
         </p:txBody>
@@ -3235,12 +3235,12 @@
             <a:pPr>
               <a:defRPr sz="1300">
                 <a:solidFill>
-                  <a:srgbClr val="94A3B8"/>
-                </a:solidFill>
-              </a:defRPr>
-            </a:pPr>
-            <a:r>
-              <a:t>Solving the liquidity crisis for 40M+ street vendors in India, replacing predatory debt with algorithmic daily capital and climate protection.</a:t>
+                  <a:srgbClr val="334155"/>
+                </a:solidFill>
+              </a:defRPr>
+            </a:pPr>
+            <a:r>
+              <a:t>Replacing 300%+ APR predatory debt for 40M unbanked street vendors in India with 4:30 AM algorithmic working capital, daily UPI micro-skimming, and autonomous climate protection.</a:t>
             </a:r>
           </a:p>
         </p:txBody>
@@ -3260,11 +3260,11 @@
             <a:avLst/>
           </a:prstGeom>
           <a:solidFill>
-            <a:srgbClr val="121826"/>
+            <a:srgbClr val="F8FAFC"/>
           </a:solidFill>
           <a:ln>
             <a:solidFill>
-              <a:srgbClr val="1E293B"/>
+              <a:srgbClr val="E2E8F0"/>
             </a:solidFill>
           </a:ln>
         </p:spPr>
@@ -3315,7 +3315,7 @@
             <a:pPr>
               <a:defRPr sz="3800" b="1">
                 <a:solidFill>
-                  <a:srgbClr val="F59E0B"/>
+                  <a:srgbClr val="D97706"/>
                 </a:solidFill>
               </a:defRPr>
             </a:pPr>
@@ -3327,7 +3327,7 @@
             <a:pPr>
               <a:defRPr sz="1200">
                 <a:solidFill>
-                  <a:srgbClr val="94A3B8"/>
+                  <a:srgbClr val="334155"/>
                 </a:solidFill>
               </a:defRPr>
             </a:pPr>
@@ -3352,11 +3352,11 @@
             <a:avLst/>
           </a:prstGeom>
           <a:solidFill>
-            <a:srgbClr val="121826"/>
+            <a:srgbClr val="F8FAFC"/>
           </a:solidFill>
           <a:ln>
             <a:solidFill>
-              <a:srgbClr val="1E293B"/>
+              <a:srgbClr val="E2E8F0"/>
             </a:solidFill>
           </a:ln>
         </p:spPr>
@@ -3407,7 +3407,7 @@
             <a:pPr>
               <a:defRPr sz="3800" b="1">
                 <a:solidFill>
-                  <a:srgbClr val="EF4444"/>
+                  <a:srgbClr val="DC2626"/>
                 </a:solidFill>
               </a:defRPr>
             </a:pPr>
@@ -3419,7 +3419,7 @@
             <a:pPr>
               <a:defRPr sz="1200">
                 <a:solidFill>
-                  <a:srgbClr val="94A3B8"/>
+                  <a:srgbClr val="334155"/>
                 </a:solidFill>
               </a:defRPr>
             </a:pPr>
@@ -3444,11 +3444,11 @@
             <a:avLst/>
           </a:prstGeom>
           <a:solidFill>
-            <a:srgbClr val="121826"/>
+            <a:srgbClr val="F8FAFC"/>
           </a:solidFill>
           <a:ln>
             <a:solidFill>
-              <a:srgbClr val="1E293B"/>
+              <a:srgbClr val="E2E8F0"/>
             </a:solidFill>
           </a:ln>
         </p:spPr>
@@ -3499,7 +3499,7 @@
             <a:pPr>
               <a:defRPr sz="3800" b="1">
                 <a:solidFill>
-                  <a:srgbClr val="10B981"/>
+                  <a:srgbClr val="059669"/>
                 </a:solidFill>
               </a:defRPr>
             </a:pPr>
@@ -3511,7 +3511,7 @@
             <a:pPr>
               <a:defRPr sz="1200">
                 <a:solidFill>
-                  <a:srgbClr val="94A3B8"/>
+                  <a:srgbClr val="334155"/>
                 </a:solidFill>
               </a:defRPr>
             </a:pPr>
@@ -3536,11 +3536,11 @@
             <a:avLst/>
           </a:prstGeom>
           <a:solidFill>
-            <a:srgbClr val="121826"/>
+            <a:srgbClr val="F8FAFC"/>
           </a:solidFill>
           <a:ln>
             <a:solidFill>
-              <a:srgbClr val="1E293B"/>
+              <a:srgbClr val="E2E8F0"/>
             </a:solidFill>
           </a:ln>
         </p:spPr>
@@ -3591,24 +3591,24 @@
             <a:pPr>
               <a:defRPr sz="3800" b="1">
                 <a:solidFill>
-                  <a:srgbClr val="06B6D4"/>
-                </a:solidFill>
-              </a:defRPr>
-            </a:pPr>
-            <a:r>
-              <a:t>&lt;10s</a:t>
+                  <a:srgbClr val="0284C7"/>
+                </a:solidFill>
+              </a:defRPr>
+            </a:pPr>
+            <a:r>
+              <a:t>&lt;60s</a:t>
             </a:r>
           </a:p>
           <a:p>
             <a:pPr>
               <a:defRPr sz="1200">
                 <a:solidFill>
-                  <a:srgbClr val="94A3B8"/>
-                </a:solidFill>
-              </a:defRPr>
-            </a:pPr>
-            <a:r>
-              <a:t>Automated Morning Disbursement Latency via Soundbox</a:t>
+                  <a:srgbClr val="334155"/>
+                </a:solidFill>
+              </a:defRPr>
+            </a:pPr>
+            <a:r>
+              <a:t>Parametric Weather Insurance Payout Without Paperwork</a:t>
             </a:r>
           </a:p>
         </p:txBody>
@@ -3646,7 +3646,7 @@
             <a:avLst/>
           </a:prstGeom>
           <a:solidFill>
-            <a:srgbClr val="0B0F17"/>
+            <a:srgbClr val="FFFFFF"/>
           </a:solidFill>
           <a:ln>
             <a:noFill/>
@@ -3699,7 +3699,7 @@
             <a:pPr>
               <a:defRPr sz="1100" b="1">
                 <a:solidFill>
-                  <a:srgbClr val="10B981"/>
+                  <a:srgbClr val="059669"/>
                 </a:solidFill>
               </a:defRPr>
             </a:pPr>
@@ -3734,7 +3734,7 @@
             <a:pPr>
               <a:defRPr sz="2800" b="1">
                 <a:solidFill>
-                  <a:srgbClr val="FFFFFF"/>
+                  <a:srgbClr val="0F172A"/>
                 </a:solidFill>
               </a:defRPr>
             </a:pPr>
@@ -3769,7 +3769,7 @@
             <a:pPr>
               <a:defRPr sz="1300">
                 <a:solidFill>
-                  <a:srgbClr val="94A3B8"/>
+                  <a:srgbClr val="334155"/>
                 </a:solidFill>
               </a:defRPr>
             </a:pPr>
@@ -3781,7 +3781,7 @@
       </p:sp>
       <p:pic>
         <p:nvPicPr>
-          <p:cNvPr id="6" name="Picture 5" descr="raju_dignity_financial_peace.jpg"/>
+          <p:cNvPr id="6" name="Picture 5" descr="stickman_dignity_restored.jpg"/>
           <p:cNvPicPr>
             <a:picLocks noChangeAspect="1"/>
           </p:cNvPicPr>
@@ -3818,11 +3818,11 @@
             <a:avLst/>
           </a:prstGeom>
           <a:solidFill>
-            <a:srgbClr val="121826"/>
+            <a:srgbClr val="F8FAFC"/>
           </a:solidFill>
           <a:ln>
             <a:solidFill>
-              <a:srgbClr val="10B981"/>
+              <a:srgbClr val="059669"/>
             </a:solidFill>
           </a:ln>
         </p:spPr>
@@ -3873,7 +3873,7 @@
             <a:pPr>
               <a:defRPr sz="1400" b="1">
                 <a:solidFill>
-                  <a:srgbClr val="FFFFFF"/>
+                  <a:srgbClr val="0F172A"/>
                 </a:solidFill>
               </a:defRPr>
             </a:pPr>
@@ -3885,7 +3885,7 @@
             <a:pPr>
               <a:defRPr sz="1100">
                 <a:solidFill>
-                  <a:srgbClr val="94A3B8"/>
+                  <a:srgbClr val="334155"/>
                 </a:solidFill>
               </a:defRPr>
             </a:pPr>
@@ -3910,11 +3910,11 @@
             <a:avLst/>
           </a:prstGeom>
           <a:solidFill>
-            <a:srgbClr val="121826"/>
+            <a:srgbClr val="F8FAFC"/>
           </a:solidFill>
           <a:ln>
             <a:solidFill>
-              <a:srgbClr val="06B6D4"/>
+              <a:srgbClr val="0284C7"/>
             </a:solidFill>
           </a:ln>
         </p:spPr>
@@ -3965,7 +3965,7 @@
             <a:pPr>
               <a:defRPr sz="1400" b="1">
                 <a:solidFill>
-                  <a:srgbClr val="FFFFFF"/>
+                  <a:srgbClr val="0F172A"/>
                 </a:solidFill>
               </a:defRPr>
             </a:pPr>
@@ -3977,7 +3977,7 @@
             <a:pPr>
               <a:defRPr sz="1100">
                 <a:solidFill>
-                  <a:srgbClr val="94A3B8"/>
+                  <a:srgbClr val="334155"/>
                 </a:solidFill>
               </a:defRPr>
             </a:pPr>
@@ -4002,11 +4002,11 @@
             <a:avLst/>
           </a:prstGeom>
           <a:solidFill>
-            <a:srgbClr val="121826"/>
+            <a:srgbClr val="F8FAFC"/>
           </a:solidFill>
           <a:ln>
             <a:solidFill>
-              <a:srgbClr val="F59E0B"/>
+              <a:srgbClr val="D97706"/>
             </a:solidFill>
           </a:ln>
         </p:spPr>
@@ -4057,7 +4057,7 @@
             <a:pPr>
               <a:defRPr sz="1400" b="1">
                 <a:solidFill>
-                  <a:srgbClr val="FFFFFF"/>
+                  <a:srgbClr val="0F172A"/>
                 </a:solidFill>
               </a:defRPr>
             </a:pPr>
@@ -4069,7 +4069,7 @@
             <a:pPr>
               <a:defRPr sz="1100">
                 <a:solidFill>
-                  <a:srgbClr val="94A3B8"/>
+                  <a:srgbClr val="334155"/>
                 </a:solidFill>
               </a:defRPr>
             </a:pPr>
@@ -4112,7 +4112,7 @@
             <a:avLst/>
           </a:prstGeom>
           <a:solidFill>
-            <a:srgbClr val="0B0F17"/>
+            <a:srgbClr val="FFFFFF"/>
           </a:solidFill>
           <a:ln>
             <a:noFill/>
@@ -4165,7 +4165,7 @@
             <a:pPr>
               <a:defRPr sz="1100" b="1">
                 <a:solidFill>
-                  <a:srgbClr val="10B981"/>
+                  <a:srgbClr val="059669"/>
                 </a:solidFill>
               </a:defRPr>
             </a:pPr>
@@ -4200,7 +4200,7 @@
             <a:pPr>
               <a:defRPr sz="2800" b="1">
                 <a:solidFill>
-                  <a:srgbClr val="FFFFFF"/>
+                  <a:srgbClr val="0F172A"/>
                 </a:solidFill>
               </a:defRPr>
             </a:pPr>
@@ -4235,7 +4235,7 @@
             <a:pPr>
               <a:defRPr sz="1300">
                 <a:solidFill>
-                  <a:srgbClr val="94A3B8"/>
+                  <a:srgbClr val="334155"/>
                 </a:solidFill>
               </a:defRPr>
             </a:pPr>
@@ -4260,11 +4260,11 @@
             <a:avLst/>
           </a:prstGeom>
           <a:solidFill>
-            <a:srgbClr val="121826"/>
+            <a:srgbClr val="F8FAFC"/>
           </a:solidFill>
           <a:ln>
             <a:solidFill>
-              <a:srgbClr val="F59E0B"/>
+              <a:srgbClr val="D97706"/>
             </a:solidFill>
           </a:ln>
         </p:spPr>
@@ -4292,7 +4292,7 @@
       </p:sp>
       <p:pic>
         <p:nvPicPr>
-          <p:cNvPr id="7" name="Picture 6" descr="raju_dawn_mandi.jpg"/>
+          <p:cNvPr id="7" name="Picture 6" descr="stickman_raju_mandi.jpg"/>
           <p:cNvPicPr>
             <a:picLocks noChangeAspect="1"/>
           </p:cNvPicPr>
@@ -4306,8 +4306,8 @@
         </p:blipFill>
         <p:spPr>
           <a:xfrm>
-            <a:off x="731520" y="2240280"/>
-            <a:ext cx="3383280" cy="2011680"/>
+            <a:off x="822960" y="2331720"/>
+            <a:ext cx="3200400" cy="2194560"/>
           </a:xfrm>
           <a:prstGeom prst="rect">
             <a:avLst/>
@@ -4322,8 +4322,8 @@
         </p:nvSpPr>
         <p:spPr>
           <a:xfrm>
-            <a:off x="914400" y="4389120"/>
-            <a:ext cx="3017520" cy="1828800"/>
+            <a:off x="914400" y="4617720"/>
+            <a:ext cx="3017520" cy="1645920"/>
           </a:xfrm>
           <a:prstGeom prst="rect">
             <a:avLst/>
@@ -4339,7 +4339,7 @@
             <a:pPr>
               <a:defRPr sz="1400" b="1">
                 <a:solidFill>
-                  <a:srgbClr val="FFFFFF"/>
+                  <a:srgbClr val="0F172A"/>
                 </a:solidFill>
               </a:defRPr>
             </a:pPr>
@@ -4351,7 +4351,7 @@
             <a:pPr>
               <a:defRPr sz="1100">
                 <a:solidFill>
-                  <a:srgbClr val="94A3B8"/>
+                  <a:srgbClr val="334155"/>
                 </a:solidFill>
               </a:defRPr>
             </a:pPr>
@@ -4376,11 +4376,11 @@
             <a:avLst/>
           </a:prstGeom>
           <a:solidFill>
-            <a:srgbClr val="121826"/>
+            <a:srgbClr val="F8FAFC"/>
           </a:solidFill>
           <a:ln>
             <a:solidFill>
-              <a:srgbClr val="EF4444"/>
+              <a:srgbClr val="DC2626"/>
             </a:solidFill>
           </a:ln>
         </p:spPr>
@@ -4408,7 +4408,7 @@
       </p:sp>
       <p:pic>
         <p:nvPicPr>
-          <p:cNvPr id="10" name="Picture 9" descr="predatory_loan_shark.jpg"/>
+          <p:cNvPr id="10" name="Picture 9" descr="stickman_loan_shark.jpg"/>
           <p:cNvPicPr>
             <a:picLocks noChangeAspect="1"/>
           </p:cNvPicPr>
@@ -4422,8 +4422,8 @@
         </p:blipFill>
         <p:spPr>
           <a:xfrm>
-            <a:off x="4343400" y="2240280"/>
-            <a:ext cx="3383280" cy="2011680"/>
+            <a:off x="4434840" y="2331720"/>
+            <a:ext cx="3200400" cy="2194560"/>
           </a:xfrm>
           <a:prstGeom prst="rect">
             <a:avLst/>
@@ -4438,8 +4438,8 @@
         </p:nvSpPr>
         <p:spPr>
           <a:xfrm>
-            <a:off x="4526280" y="4389120"/>
-            <a:ext cx="3017520" cy="1828800"/>
+            <a:off x="4526280" y="4617720"/>
+            <a:ext cx="3017520" cy="1645920"/>
           </a:xfrm>
           <a:prstGeom prst="rect">
             <a:avLst/>
@@ -4455,7 +4455,7 @@
             <a:pPr>
               <a:defRPr sz="1400" b="1">
                 <a:solidFill>
-                  <a:srgbClr val="FFFFFF"/>
+                  <a:srgbClr val="0F172A"/>
                 </a:solidFill>
               </a:defRPr>
             </a:pPr>
@@ -4467,7 +4467,7 @@
             <a:pPr>
               <a:defRPr sz="1100">
                 <a:solidFill>
-                  <a:srgbClr val="94A3B8"/>
+                  <a:srgbClr val="334155"/>
                 </a:solidFill>
               </a:defRPr>
             </a:pPr>
@@ -4492,11 +4492,11 @@
             <a:avLst/>
           </a:prstGeom>
           <a:solidFill>
-            <a:srgbClr val="121826"/>
+            <a:srgbClr val="F8FAFC"/>
           </a:solidFill>
           <a:ln>
             <a:solidFill>
-              <a:srgbClr val="06B6D4"/>
+              <a:srgbClr val="0284C7"/>
             </a:solidFill>
           </a:ln>
         </p:spPr>
@@ -4524,7 +4524,7 @@
       </p:sp>
       <p:pic>
         <p:nvPicPr>
-          <p:cNvPr id="13" name="Picture 12" descr="monsoon_climate_shock.jpg"/>
+          <p:cNvPr id="13" name="Picture 12" descr="stickman_climate_shock.jpg"/>
           <p:cNvPicPr>
             <a:picLocks noChangeAspect="1"/>
           </p:cNvPicPr>
@@ -4538,8 +4538,8 @@
         </p:blipFill>
         <p:spPr>
           <a:xfrm>
-            <a:off x="7955280" y="2240280"/>
-            <a:ext cx="3383280" cy="2011680"/>
+            <a:off x="8046720" y="2331720"/>
+            <a:ext cx="3200400" cy="2194560"/>
           </a:xfrm>
           <a:prstGeom prst="rect">
             <a:avLst/>
@@ -4554,8 +4554,8 @@
         </p:nvSpPr>
         <p:spPr>
           <a:xfrm>
-            <a:off x="8138160" y="4389120"/>
-            <a:ext cx="3017520" cy="1828800"/>
+            <a:off x="8138160" y="4617720"/>
+            <a:ext cx="3017520" cy="1645920"/>
           </a:xfrm>
           <a:prstGeom prst="rect">
             <a:avLst/>
@@ -4571,7 +4571,7 @@
             <a:pPr>
               <a:defRPr sz="1400" b="1">
                 <a:solidFill>
-                  <a:srgbClr val="FFFFFF"/>
+                  <a:srgbClr val="0F172A"/>
                 </a:solidFill>
               </a:defRPr>
             </a:pPr>
@@ -4583,7 +4583,7 @@
             <a:pPr>
               <a:defRPr sz="1100">
                 <a:solidFill>
-                  <a:srgbClr val="94A3B8"/>
+                  <a:srgbClr val="334155"/>
                 </a:solidFill>
               </a:defRPr>
             </a:pPr>
@@ -4626,7 +4626,7 @@
             <a:avLst/>
           </a:prstGeom>
           <a:solidFill>
-            <a:srgbClr val="0B0F17"/>
+            <a:srgbClr val="FFFFFF"/>
           </a:solidFill>
           <a:ln>
             <a:noFill/>
@@ -4679,7 +4679,7 @@
             <a:pPr>
               <a:defRPr sz="1100" b="1">
                 <a:solidFill>
-                  <a:srgbClr val="10B981"/>
+                  <a:srgbClr val="059669"/>
                 </a:solidFill>
               </a:defRPr>
             </a:pPr>
@@ -4714,7 +4714,7 @@
             <a:pPr>
               <a:defRPr sz="2800" b="1">
                 <a:solidFill>
-                  <a:srgbClr val="FFFFFF"/>
+                  <a:srgbClr val="0F172A"/>
                 </a:solidFill>
               </a:defRPr>
             </a:pPr>
@@ -4749,7 +4749,7 @@
             <a:pPr>
               <a:defRPr sz="1300">
                 <a:solidFill>
-                  <a:srgbClr val="94A3B8"/>
+                  <a:srgbClr val="334155"/>
                 </a:solidFill>
               </a:defRPr>
             </a:pPr>
@@ -4792,7 +4792,7 @@
                       <a:pPr>
                         <a:defRPr sz="1200" b="1">
                           <a:solidFill>
-                            <a:srgbClr val="FFFFFF"/>
+                            <a:srgbClr val="0F172A"/>
                           </a:solidFill>
                         </a:defRPr>
                       </a:pPr>
@@ -4803,7 +4803,7 @@
                   </a:txBody>
                   <a:tcPr>
                     <a:solidFill>
-                      <a:srgbClr val="1E293B"/>
+                      <a:srgbClr val="F1F5F9"/>
                     </a:solidFill>
                   </a:tcPr>
                 </a:tc>
@@ -4815,7 +4815,7 @@
                       <a:pPr>
                         <a:defRPr sz="1200" b="1">
                           <a:solidFill>
-                            <a:srgbClr val="FFFFFF"/>
+                            <a:srgbClr val="0F172A"/>
                           </a:solidFill>
                         </a:defRPr>
                       </a:pPr>
@@ -4826,7 +4826,7 @@
                   </a:txBody>
                   <a:tcPr>
                     <a:solidFill>
-                      <a:srgbClr val="1E293B"/>
+                      <a:srgbClr val="F1F5F9"/>
                     </a:solidFill>
                   </a:tcPr>
                 </a:tc>
@@ -4838,7 +4838,7 @@
                       <a:pPr>
                         <a:defRPr sz="1200" b="1">
                           <a:solidFill>
-                            <a:srgbClr val="FFFFFF"/>
+                            <a:srgbClr val="0F172A"/>
                           </a:solidFill>
                         </a:defRPr>
                       </a:pPr>
@@ -4849,7 +4849,7 @@
                   </a:txBody>
                   <a:tcPr>
                     <a:solidFill>
-                      <a:srgbClr val="1E293B"/>
+                      <a:srgbClr val="F1F5F9"/>
                     </a:solidFill>
                   </a:tcPr>
                 </a:tc>
@@ -4872,7 +4872,7 @@
                   </a:txBody>
                   <a:tcPr>
                     <a:solidFill>
-                      <a:srgbClr val="10B981"/>
+                      <a:srgbClr val="059669"/>
                     </a:solidFill>
                   </a:tcPr>
                 </a:tc>
@@ -4886,7 +4886,7 @@
                       <a:pPr>
                         <a:defRPr sz="1100" b="1">
                           <a:solidFill>
-                            <a:srgbClr val="FFFFFF"/>
+                            <a:srgbClr val="0F172A"/>
                           </a:solidFill>
                         </a:defRPr>
                       </a:pPr>
@@ -4897,7 +4897,7 @@
                   </a:txBody>
                   <a:tcPr>
                     <a:solidFill>
-                      <a:srgbClr val="121826"/>
+                      <a:srgbClr val="F8FAFC"/>
                     </a:solidFill>
                   </a:tcPr>
                 </a:tc>
@@ -4909,7 +4909,7 @@
                       <a:pPr>
                         <a:defRPr sz="1100" b="0">
                           <a:solidFill>
-                            <a:srgbClr val="FFFFFF"/>
+                            <a:srgbClr val="0F172A"/>
                           </a:solidFill>
                         </a:defRPr>
                       </a:pPr>
@@ -4920,7 +4920,7 @@
                   </a:txBody>
                   <a:tcPr>
                     <a:solidFill>
-                      <a:srgbClr val="121826"/>
+                      <a:srgbClr val="F8FAFC"/>
                     </a:solidFill>
                   </a:tcPr>
                 </a:tc>
@@ -4932,7 +4932,7 @@
                       <a:pPr>
                         <a:defRPr sz="1100" b="0">
                           <a:solidFill>
-                            <a:srgbClr val="FFFFFF"/>
+                            <a:srgbClr val="0F172A"/>
                           </a:solidFill>
                         </a:defRPr>
                       </a:pPr>
@@ -4943,7 +4943,7 @@
                   </a:txBody>
                   <a:tcPr>
                     <a:solidFill>
-                      <a:srgbClr val="121826"/>
+                      <a:srgbClr val="F8FAFC"/>
                     </a:solidFill>
                   </a:tcPr>
                 </a:tc>
@@ -4955,7 +4955,7 @@
                       <a:pPr>
                         <a:defRPr sz="1100" b="1">
                           <a:solidFill>
-                            <a:srgbClr val="FFFFFF"/>
+                            <a:srgbClr val="065F46"/>
                           </a:solidFill>
                         </a:defRPr>
                       </a:pPr>
@@ -4966,7 +4966,7 @@
                   </a:txBody>
                   <a:tcPr>
                     <a:solidFill>
-                      <a:srgbClr val="0F231E"/>
+                      <a:srgbClr val="ECFDF5"/>
                     </a:solidFill>
                   </a:tcPr>
                 </a:tc>
@@ -4980,7 +4980,7 @@
                       <a:pPr>
                         <a:defRPr sz="1100" b="1">
                           <a:solidFill>
-                            <a:srgbClr val="FFFFFF"/>
+                            <a:srgbClr val="0F172A"/>
                           </a:solidFill>
                         </a:defRPr>
                       </a:pPr>
@@ -4991,7 +4991,7 @@
                   </a:txBody>
                   <a:tcPr>
                     <a:solidFill>
-                      <a:srgbClr val="121826"/>
+                      <a:srgbClr val="F8FAFC"/>
                     </a:solidFill>
                   </a:tcPr>
                 </a:tc>
@@ -5003,7 +5003,7 @@
                       <a:pPr>
                         <a:defRPr sz="1100" b="0">
                           <a:solidFill>
-                            <a:srgbClr val="FFFFFF"/>
+                            <a:srgbClr val="0F172A"/>
                           </a:solidFill>
                         </a:defRPr>
                       </a:pPr>
@@ -5014,7 +5014,7 @@
                   </a:txBody>
                   <a:tcPr>
                     <a:solidFill>
-                      <a:srgbClr val="121826"/>
+                      <a:srgbClr val="F8FAFC"/>
                     </a:solidFill>
                   </a:tcPr>
                 </a:tc>
@@ -5026,7 +5026,7 @@
                       <a:pPr>
                         <a:defRPr sz="1100" b="0">
                           <a:solidFill>
-                            <a:srgbClr val="FFFFFF"/>
+                            <a:srgbClr val="0F172A"/>
                           </a:solidFill>
                         </a:defRPr>
                       </a:pPr>
@@ -5037,7 +5037,7 @@
                   </a:txBody>
                   <a:tcPr>
                     <a:solidFill>
-                      <a:srgbClr val="121826"/>
+                      <a:srgbClr val="F8FAFC"/>
                     </a:solidFill>
                   </a:tcPr>
                 </a:tc>
@@ -5049,7 +5049,7 @@
                       <a:pPr>
                         <a:defRPr sz="1100" b="1">
                           <a:solidFill>
-                            <a:srgbClr val="FFFFFF"/>
+                            <a:srgbClr val="065F46"/>
                           </a:solidFill>
                         </a:defRPr>
                       </a:pPr>
@@ -5060,7 +5060,7 @@
                   </a:txBody>
                   <a:tcPr>
                     <a:solidFill>
-                      <a:srgbClr val="0F231E"/>
+                      <a:srgbClr val="ECFDF5"/>
                     </a:solidFill>
                   </a:tcPr>
                 </a:tc>
@@ -5074,7 +5074,7 @@
                       <a:pPr>
                         <a:defRPr sz="1100" b="1">
                           <a:solidFill>
-                            <a:srgbClr val="FFFFFF"/>
+                            <a:srgbClr val="0F172A"/>
                           </a:solidFill>
                         </a:defRPr>
                       </a:pPr>
@@ -5085,7 +5085,7 @@
                   </a:txBody>
                   <a:tcPr>
                     <a:solidFill>
-                      <a:srgbClr val="121826"/>
+                      <a:srgbClr val="F8FAFC"/>
                     </a:solidFill>
                   </a:tcPr>
                 </a:tc>
@@ -5097,7 +5097,7 @@
                       <a:pPr>
                         <a:defRPr sz="1100" b="0">
                           <a:solidFill>
-                            <a:srgbClr val="FFFFFF"/>
+                            <a:srgbClr val="0F172A"/>
                           </a:solidFill>
                         </a:defRPr>
                       </a:pPr>
@@ -5108,7 +5108,7 @@
                   </a:txBody>
                   <a:tcPr>
                     <a:solidFill>
-                      <a:srgbClr val="121826"/>
+                      <a:srgbClr val="F8FAFC"/>
                     </a:solidFill>
                   </a:tcPr>
                 </a:tc>
@@ -5120,7 +5120,7 @@
                       <a:pPr>
                         <a:defRPr sz="1100" b="0">
                           <a:solidFill>
-                            <a:srgbClr val="FFFFFF"/>
+                            <a:srgbClr val="0F172A"/>
                           </a:solidFill>
                         </a:defRPr>
                       </a:pPr>
@@ -5131,7 +5131,7 @@
                   </a:txBody>
                   <a:tcPr>
                     <a:solidFill>
-                      <a:srgbClr val="121826"/>
+                      <a:srgbClr val="F8FAFC"/>
                     </a:solidFill>
                   </a:tcPr>
                 </a:tc>
@@ -5143,7 +5143,7 @@
                       <a:pPr>
                         <a:defRPr sz="1100" b="1">
                           <a:solidFill>
-                            <a:srgbClr val="FFFFFF"/>
+                            <a:srgbClr val="065F46"/>
                           </a:solidFill>
                         </a:defRPr>
                       </a:pPr>
@@ -5154,7 +5154,7 @@
                   </a:txBody>
                   <a:tcPr>
                     <a:solidFill>
-                      <a:srgbClr val="0F231E"/>
+                      <a:srgbClr val="ECFDF5"/>
                     </a:solidFill>
                   </a:tcPr>
                 </a:tc>
@@ -5168,7 +5168,7 @@
                       <a:pPr>
                         <a:defRPr sz="1100" b="1">
                           <a:solidFill>
-                            <a:srgbClr val="FFFFFF"/>
+                            <a:srgbClr val="0F172A"/>
                           </a:solidFill>
                         </a:defRPr>
                       </a:pPr>
@@ -5179,7 +5179,7 @@
                   </a:txBody>
                   <a:tcPr>
                     <a:solidFill>
-                      <a:srgbClr val="121826"/>
+                      <a:srgbClr val="F8FAFC"/>
                     </a:solidFill>
                   </a:tcPr>
                 </a:tc>
@@ -5191,7 +5191,7 @@
                       <a:pPr>
                         <a:defRPr sz="1100" b="0">
                           <a:solidFill>
-                            <a:srgbClr val="FFFFFF"/>
+                            <a:srgbClr val="0F172A"/>
                           </a:solidFill>
                         </a:defRPr>
                       </a:pPr>
@@ -5202,7 +5202,7 @@
                   </a:txBody>
                   <a:tcPr>
                     <a:solidFill>
-                      <a:srgbClr val="121826"/>
+                      <a:srgbClr val="F8FAFC"/>
                     </a:solidFill>
                   </a:tcPr>
                 </a:tc>
@@ -5214,7 +5214,7 @@
                       <a:pPr>
                         <a:defRPr sz="1100" b="0">
                           <a:solidFill>
-                            <a:srgbClr val="FFFFFF"/>
+                            <a:srgbClr val="0F172A"/>
                           </a:solidFill>
                         </a:defRPr>
                       </a:pPr>
@@ -5225,7 +5225,7 @@
                   </a:txBody>
                   <a:tcPr>
                     <a:solidFill>
-                      <a:srgbClr val="121826"/>
+                      <a:srgbClr val="F8FAFC"/>
                     </a:solidFill>
                   </a:tcPr>
                 </a:tc>
@@ -5237,7 +5237,7 @@
                       <a:pPr>
                         <a:defRPr sz="1100" b="1">
                           <a:solidFill>
-                            <a:srgbClr val="FFFFFF"/>
+                            <a:srgbClr val="065F46"/>
                           </a:solidFill>
                         </a:defRPr>
                       </a:pPr>
@@ -5248,7 +5248,7 @@
                   </a:txBody>
                   <a:tcPr>
                     <a:solidFill>
-                      <a:srgbClr val="0F231E"/>
+                      <a:srgbClr val="ECFDF5"/>
                     </a:solidFill>
                   </a:tcPr>
                 </a:tc>
@@ -5290,7 +5290,7 @@
             <a:avLst/>
           </a:prstGeom>
           <a:solidFill>
-            <a:srgbClr val="0B0F17"/>
+            <a:srgbClr val="FFFFFF"/>
           </a:solidFill>
           <a:ln>
             <a:noFill/>
@@ -5343,7 +5343,7 @@
             <a:pPr>
               <a:defRPr sz="1100" b="1">
                 <a:solidFill>
-                  <a:srgbClr val="10B981"/>
+                  <a:srgbClr val="059669"/>
                 </a:solidFill>
               </a:defRPr>
             </a:pPr>
@@ -5378,7 +5378,7 @@
             <a:pPr>
               <a:defRPr sz="2800" b="1">
                 <a:solidFill>
-                  <a:srgbClr val="FFFFFF"/>
+                  <a:srgbClr val="0F172A"/>
                 </a:solidFill>
               </a:defRPr>
             </a:pPr>
@@ -5413,7 +5413,7 @@
             <a:pPr>
               <a:defRPr sz="1300">
                 <a:solidFill>
-                  <a:srgbClr val="94A3B8"/>
+                  <a:srgbClr val="334155"/>
                 </a:solidFill>
               </a:defRPr>
             </a:pPr>
@@ -5438,11 +5438,11 @@
             <a:avLst/>
           </a:prstGeom>
           <a:solidFill>
-            <a:srgbClr val="121826"/>
+            <a:srgbClr val="F8FAFC"/>
           </a:solidFill>
           <a:ln>
             <a:solidFill>
-              <a:srgbClr val="F59E0B"/>
+              <a:srgbClr val="D97706"/>
             </a:solidFill>
           </a:ln>
         </p:spPr>
@@ -5493,7 +5493,7 @@
             <a:pPr>
               <a:defRPr sz="1500" b="1">
                 <a:solidFill>
-                  <a:srgbClr val="FFFFFF"/>
+                  <a:srgbClr val="0F172A"/>
                 </a:solidFill>
               </a:defRPr>
             </a:pPr>
@@ -5505,7 +5505,7 @@
             <a:pPr>
               <a:defRPr sz="1200">
                 <a:solidFill>
-                  <a:srgbClr val="94A3B8"/>
+                  <a:srgbClr val="334155"/>
                 </a:solidFill>
               </a:defRPr>
             </a:pPr>
@@ -5530,11 +5530,11 @@
             <a:avLst/>
           </a:prstGeom>
           <a:solidFill>
-            <a:srgbClr val="121826"/>
+            <a:srgbClr val="F8FAFC"/>
           </a:solidFill>
           <a:ln>
             <a:solidFill>
-              <a:srgbClr val="10B981"/>
+              <a:srgbClr val="059669"/>
             </a:solidFill>
           </a:ln>
         </p:spPr>
@@ -5585,7 +5585,7 @@
             <a:pPr>
               <a:defRPr sz="1500" b="1">
                 <a:solidFill>
-                  <a:srgbClr val="FFFFFF"/>
+                  <a:srgbClr val="0F172A"/>
                 </a:solidFill>
               </a:defRPr>
             </a:pPr>
@@ -5597,7 +5597,7 @@
             <a:pPr>
               <a:defRPr sz="1200">
                 <a:solidFill>
-                  <a:srgbClr val="94A3B8"/>
+                  <a:srgbClr val="334155"/>
                 </a:solidFill>
               </a:defRPr>
             </a:pPr>
@@ -5622,11 +5622,11 @@
             <a:avLst/>
           </a:prstGeom>
           <a:solidFill>
-            <a:srgbClr val="121826"/>
+            <a:srgbClr val="F8FAFC"/>
           </a:solidFill>
           <a:ln>
             <a:solidFill>
-              <a:srgbClr val="06B6D4"/>
+              <a:srgbClr val="0284C7"/>
             </a:solidFill>
           </a:ln>
         </p:spPr>
@@ -5677,7 +5677,7 @@
             <a:pPr>
               <a:defRPr sz="1500" b="1">
                 <a:solidFill>
-                  <a:srgbClr val="FFFFFF"/>
+                  <a:srgbClr val="0F172A"/>
                 </a:solidFill>
               </a:defRPr>
             </a:pPr>
@@ -5689,7 +5689,7 @@
             <a:pPr>
               <a:defRPr sz="1200">
                 <a:solidFill>
-                  <a:srgbClr val="94A3B8"/>
+                  <a:srgbClr val="334155"/>
                 </a:solidFill>
               </a:defRPr>
             </a:pPr>
@@ -5714,11 +5714,11 @@
             <a:avLst/>
           </a:prstGeom>
           <a:solidFill>
-            <a:srgbClr val="121826"/>
+            <a:srgbClr val="F8FAFC"/>
           </a:solidFill>
           <a:ln>
             <a:solidFill>
-              <a:srgbClr val="10B981"/>
+              <a:srgbClr val="059669"/>
             </a:solidFill>
           </a:ln>
         </p:spPr>
@@ -5769,7 +5769,7 @@
             <a:pPr>
               <a:defRPr sz="1500" b="1">
                 <a:solidFill>
-                  <a:srgbClr val="FFFFFF"/>
+                  <a:srgbClr val="0F172A"/>
                 </a:solidFill>
               </a:defRPr>
             </a:pPr>
@@ -5781,7 +5781,7 @@
             <a:pPr>
               <a:defRPr sz="1200">
                 <a:solidFill>
-                  <a:srgbClr val="94A3B8"/>
+                  <a:srgbClr val="334155"/>
                 </a:solidFill>
               </a:defRPr>
             </a:pPr>
@@ -5824,7 +5824,7 @@
             <a:avLst/>
           </a:prstGeom>
           <a:solidFill>
-            <a:srgbClr val="0B0F17"/>
+            <a:srgbClr val="FFFFFF"/>
           </a:solidFill>
           <a:ln>
             <a:noFill/>
@@ -5877,7 +5877,7 @@
             <a:pPr>
               <a:defRPr sz="1100" b="1">
                 <a:solidFill>
-                  <a:srgbClr val="10B981"/>
+                  <a:srgbClr val="059669"/>
                 </a:solidFill>
               </a:defRPr>
             </a:pPr>
@@ -5912,7 +5912,7 @@
             <a:pPr>
               <a:defRPr sz="2800" b="1">
                 <a:solidFill>
-                  <a:srgbClr val="FFFFFF"/>
+                  <a:srgbClr val="0F172A"/>
                 </a:solidFill>
               </a:defRPr>
             </a:pPr>
@@ -5947,7 +5947,7 @@
             <a:pPr>
               <a:defRPr sz="1300">
                 <a:solidFill>
-                  <a:srgbClr val="94A3B8"/>
+                  <a:srgbClr val="334155"/>
                 </a:solidFill>
               </a:defRPr>
             </a:pPr>
@@ -5982,7 +5982,7 @@
             <a:pPr>
               <a:defRPr sz="1300" b="1">
                 <a:solidFill>
-                  <a:srgbClr val="F59E0B"/>
+                  <a:srgbClr val="D97706"/>
                 </a:solidFill>
               </a:defRPr>
             </a:pPr>
@@ -5994,7 +5994,7 @@
             <a:pPr>
               <a:defRPr sz="1100">
                 <a:solidFill>
-                  <a:srgbClr val="94A3B8"/>
+                  <a:srgbClr val="334155"/>
                 </a:solidFill>
               </a:defRPr>
             </a:pPr>
@@ -6029,7 +6029,7 @@
             <a:pPr>
               <a:defRPr sz="1300" b="1">
                 <a:solidFill>
-                  <a:srgbClr val="10B981"/>
+                  <a:srgbClr val="059669"/>
                 </a:solidFill>
               </a:defRPr>
             </a:pPr>
@@ -6041,7 +6041,7 @@
             <a:pPr>
               <a:defRPr sz="1100">
                 <a:solidFill>
-                  <a:srgbClr val="94A3B8"/>
+                  <a:srgbClr val="334155"/>
                 </a:solidFill>
               </a:defRPr>
             </a:pPr>
@@ -6076,7 +6076,7 @@
             <a:pPr>
               <a:defRPr sz="1300" b="1">
                 <a:solidFill>
-                  <a:srgbClr val="EF4444"/>
+                  <a:srgbClr val="DC2626"/>
                 </a:solidFill>
               </a:defRPr>
             </a:pPr>
@@ -6088,7 +6088,7 @@
             <a:pPr>
               <a:defRPr sz="1100">
                 <a:solidFill>
-                  <a:srgbClr val="94A3B8"/>
+                  <a:srgbClr val="334155"/>
                 </a:solidFill>
               </a:defRPr>
             </a:pPr>
@@ -6123,7 +6123,7 @@
             <a:pPr>
               <a:defRPr sz="1300" b="1">
                 <a:solidFill>
-                  <a:srgbClr val="06B6D4"/>
+                  <a:srgbClr val="0284C7"/>
                 </a:solidFill>
               </a:defRPr>
             </a:pPr>
@@ -6135,7 +6135,7 @@
             <a:pPr>
               <a:defRPr sz="1100">
                 <a:solidFill>
-                  <a:srgbClr val="94A3B8"/>
+                  <a:srgbClr val="334155"/>
                 </a:solidFill>
               </a:defRPr>
             </a:pPr>
@@ -6147,7 +6147,7 @@
       </p:sp>
       <p:pic>
         <p:nvPicPr>
-          <p:cNvPr id="10" name="Picture 9" descr="finflow_soundbox_terminal.jpg"/>
+          <p:cNvPr id="10" name="Picture 9" descr="stickman_soundbox_split.jpg"/>
           <p:cNvPicPr>
             <a:picLocks noChangeAspect="1"/>
           </p:cNvPicPr>
@@ -6202,7 +6202,7 @@
             <a:avLst/>
           </a:prstGeom>
           <a:solidFill>
-            <a:srgbClr val="0B0F17"/>
+            <a:srgbClr val="FFFFFF"/>
           </a:solidFill>
           <a:ln>
             <a:noFill/>
@@ -6255,7 +6255,7 @@
             <a:pPr>
               <a:defRPr sz="1100" b="1">
                 <a:solidFill>
-                  <a:srgbClr val="10B981"/>
+                  <a:srgbClr val="059669"/>
                 </a:solidFill>
               </a:defRPr>
             </a:pPr>
@@ -6290,7 +6290,7 @@
             <a:pPr>
               <a:defRPr sz="2800" b="1">
                 <a:solidFill>
-                  <a:srgbClr val="FFFFFF"/>
+                  <a:srgbClr val="0F172A"/>
                 </a:solidFill>
               </a:defRPr>
             </a:pPr>
@@ -6325,7 +6325,7 @@
             <a:pPr>
               <a:defRPr sz="1300">
                 <a:solidFill>
-                  <a:srgbClr val="94A3B8"/>
+                  <a:srgbClr val="334155"/>
                 </a:solidFill>
               </a:defRPr>
             </a:pPr>
@@ -6337,7 +6337,7 @@
       </p:sp>
       <p:pic>
         <p:nvPicPr>
-          <p:cNvPr id="6" name="Picture 5" descr="finflow_bank_dashboard.jpg"/>
+          <p:cNvPr id="6" name="Picture 5" descr="stickman_soundbox_split.jpg"/>
           <p:cNvPicPr>
             <a:picLocks noChangeAspect="1"/>
           </p:cNvPicPr>
@@ -6374,11 +6374,11 @@
             <a:avLst/>
           </a:prstGeom>
           <a:solidFill>
-            <a:srgbClr val="121826"/>
+            <a:srgbClr val="F8FAFC"/>
           </a:solidFill>
           <a:ln>
             <a:solidFill>
-              <a:srgbClr val="1E293B"/>
+              <a:srgbClr val="E2E8F0"/>
             </a:solidFill>
           </a:ln>
         </p:spPr>
@@ -6429,7 +6429,7 @@
             <a:pPr>
               <a:defRPr sz="1300" b="1">
                 <a:solidFill>
-                  <a:srgbClr val="FFFFFF"/>
+                  <a:srgbClr val="0F172A"/>
                 </a:solidFill>
               </a:defRPr>
             </a:pPr>
@@ -6441,12 +6441,12 @@
             <a:pPr>
               <a:defRPr sz="1100">
                 <a:solidFill>
-                  <a:srgbClr val="94A3B8"/>
-                </a:solidFill>
-              </a:defRPr>
-            </a:pPr>
-            <a:r>
-              <a:t>Instantaneous multi-split routing between vendor spendable wallet, NBFC loan vault, and Goolak on NPCI settlement webhooks.</a:t>
+                  <a:srgbClr val="334155"/>
+                </a:solidFill>
+              </a:defRPr>
+            </a:pPr>
+            <a:r>
+              <a:t>Instantaneous multi-split routing between vendor spendable wallet, SFB loan vault, and Goolak on NPCI settlement webhooks.</a:t>
             </a:r>
           </a:p>
         </p:txBody>
@@ -6466,11 +6466,11 @@
             <a:avLst/>
           </a:prstGeom>
           <a:solidFill>
-            <a:srgbClr val="121826"/>
+            <a:srgbClr val="F8FAFC"/>
           </a:solidFill>
           <a:ln>
             <a:solidFill>
-              <a:srgbClr val="1E293B"/>
+              <a:srgbClr val="E2E8F0"/>
             </a:solidFill>
           </a:ln>
         </p:spPr>
@@ -6521,7 +6521,7 @@
             <a:pPr>
               <a:defRPr sz="1300" b="1">
                 <a:solidFill>
-                  <a:srgbClr val="FFFFFF"/>
+                  <a:srgbClr val="0F172A"/>
                 </a:solidFill>
               </a:defRPr>
             </a:pPr>
@@ -6533,7 +6533,7 @@
             <a:pPr>
               <a:defRPr sz="1100">
                 <a:solidFill>
-                  <a:srgbClr val="94A3B8"/>
+                  <a:srgbClr val="334155"/>
                 </a:solidFill>
               </a:defRPr>
             </a:pPr>
@@ -6558,11 +6558,11 @@
             <a:avLst/>
           </a:prstGeom>
           <a:solidFill>
-            <a:srgbClr val="121826"/>
+            <a:srgbClr val="F8FAFC"/>
           </a:solidFill>
           <a:ln>
             <a:solidFill>
-              <a:srgbClr val="1E293B"/>
+              <a:srgbClr val="E2E8F0"/>
             </a:solidFill>
           </a:ln>
         </p:spPr>
@@ -6613,7 +6613,7 @@
             <a:pPr>
               <a:defRPr sz="1300" b="1">
                 <a:solidFill>
-                  <a:srgbClr val="FFFFFF"/>
+                  <a:srgbClr val="0F172A"/>
                 </a:solidFill>
               </a:defRPr>
             </a:pPr>
@@ -6625,7 +6625,7 @@
             <a:pPr>
               <a:defRPr sz="1100">
                 <a:solidFill>
-                  <a:srgbClr val="94A3B8"/>
+                  <a:srgbClr val="334155"/>
                 </a:solidFill>
               </a:defRPr>
             </a:pPr>
@@ -6668,7 +6668,7 @@
             <a:avLst/>
           </a:prstGeom>
           <a:solidFill>
-            <a:srgbClr val="0B0F17"/>
+            <a:srgbClr val="FFFFFF"/>
           </a:solidFill>
           <a:ln>
             <a:noFill/>
@@ -6721,7 +6721,7 @@
             <a:pPr>
               <a:defRPr sz="1100" b="1">
                 <a:solidFill>
-                  <a:srgbClr val="10B981"/>
+                  <a:srgbClr val="059669"/>
                 </a:solidFill>
               </a:defRPr>
             </a:pPr>
@@ -6756,7 +6756,7 @@
             <a:pPr>
               <a:defRPr sz="2800" b="1">
                 <a:solidFill>
-                  <a:srgbClr val="FFFFFF"/>
+                  <a:srgbClr val="0F172A"/>
                 </a:solidFill>
               </a:defRPr>
             </a:pPr>
@@ -6791,7 +6791,7 @@
             <a:pPr>
               <a:defRPr sz="1300">
                 <a:solidFill>
-                  <a:srgbClr val="94A3B8"/>
+                  <a:srgbClr val="334155"/>
                 </a:solidFill>
               </a:defRPr>
             </a:pPr>
@@ -6816,11 +6816,11 @@
             <a:avLst/>
           </a:prstGeom>
           <a:solidFill>
-            <a:srgbClr val="121826"/>
+            <a:srgbClr val="F8FAFC"/>
           </a:solidFill>
           <a:ln>
             <a:solidFill>
-              <a:srgbClr val="1E293B"/>
+              <a:srgbClr val="E2E8F0"/>
             </a:solidFill>
           </a:ln>
         </p:spPr>
@@ -6871,7 +6871,7 @@
             <a:pPr>
               <a:defRPr sz="3800" b="1">
                 <a:solidFill>
-                  <a:srgbClr val="F59E0B"/>
+                  <a:srgbClr val="D97706"/>
                 </a:solidFill>
               </a:defRPr>
             </a:pPr>
@@ -6883,7 +6883,7 @@
             <a:pPr>
               <a:defRPr sz="1200">
                 <a:solidFill>
-                  <a:srgbClr val="94A3B8"/>
+                  <a:srgbClr val="334155"/>
                 </a:solidFill>
               </a:defRPr>
             </a:pPr>
@@ -6908,11 +6908,11 @@
             <a:avLst/>
           </a:prstGeom>
           <a:solidFill>
-            <a:srgbClr val="121826"/>
+            <a:srgbClr val="F8FAFC"/>
           </a:solidFill>
           <a:ln>
             <a:solidFill>
-              <a:srgbClr val="1E293B"/>
+              <a:srgbClr val="E2E8F0"/>
             </a:solidFill>
           </a:ln>
         </p:spPr>
@@ -6963,7 +6963,7 @@
             <a:pPr>
               <a:defRPr sz="3800" b="1">
                 <a:solidFill>
-                  <a:srgbClr val="10B981"/>
+                  <a:srgbClr val="059669"/>
                 </a:solidFill>
               </a:defRPr>
             </a:pPr>
@@ -6975,7 +6975,7 @@
             <a:pPr>
               <a:defRPr sz="1200">
                 <a:solidFill>
-                  <a:srgbClr val="94A3B8"/>
+                  <a:srgbClr val="334155"/>
                 </a:solidFill>
               </a:defRPr>
             </a:pPr>
@@ -7000,11 +7000,11 @@
             <a:avLst/>
           </a:prstGeom>
           <a:solidFill>
-            <a:srgbClr val="121826"/>
+            <a:srgbClr val="F8FAFC"/>
           </a:solidFill>
           <a:ln>
             <a:solidFill>
-              <a:srgbClr val="1E293B"/>
+              <a:srgbClr val="E2E8F0"/>
             </a:solidFill>
           </a:ln>
         </p:spPr>
@@ -7055,7 +7055,7 @@
             <a:pPr>
               <a:defRPr sz="3800" b="1">
                 <a:solidFill>
-                  <a:srgbClr val="06B6D4"/>
+                  <a:srgbClr val="0284C7"/>
                 </a:solidFill>
               </a:defRPr>
             </a:pPr>
@@ -7067,7 +7067,7 @@
             <a:pPr>
               <a:defRPr sz="1200">
                 <a:solidFill>
-                  <a:srgbClr val="94A3B8"/>
+                  <a:srgbClr val="334155"/>
                 </a:solidFill>
               </a:defRPr>
             </a:pPr>
@@ -7092,11 +7092,11 @@
             <a:avLst/>
           </a:prstGeom>
           <a:solidFill>
-            <a:srgbClr val="121826"/>
+            <a:srgbClr val="F8FAFC"/>
           </a:solidFill>
           <a:ln>
             <a:solidFill>
-              <a:srgbClr val="1E293B"/>
+              <a:srgbClr val="E2E8F0"/>
             </a:solidFill>
           </a:ln>
         </p:spPr>
@@ -7147,7 +7147,7 @@
             <a:pPr>
               <a:defRPr sz="3800" b="1">
                 <a:solidFill>
-                  <a:srgbClr val="10B981"/>
+                  <a:srgbClr val="059669"/>
                 </a:solidFill>
               </a:defRPr>
             </a:pPr>
@@ -7159,7 +7159,7 @@
             <a:pPr>
               <a:defRPr sz="1200">
                 <a:solidFill>
-                  <a:srgbClr val="94A3B8"/>
+                  <a:srgbClr val="334155"/>
                 </a:solidFill>
               </a:defRPr>
             </a:pPr>
@@ -7202,7 +7202,7 @@
             <a:avLst/>
           </a:prstGeom>
           <a:solidFill>
-            <a:srgbClr val="0B0F17"/>
+            <a:srgbClr val="FFFFFF"/>
           </a:solidFill>
           <a:ln>
             <a:noFill/>
@@ -7255,7 +7255,7 @@
             <a:pPr>
               <a:defRPr sz="1100" b="1">
                 <a:solidFill>
-                  <a:srgbClr val="10B981"/>
+                  <a:srgbClr val="059669"/>
                 </a:solidFill>
               </a:defRPr>
             </a:pPr>
@@ -7290,7 +7290,7 @@
             <a:pPr>
               <a:defRPr sz="2800" b="1">
                 <a:solidFill>
-                  <a:srgbClr val="FFFFFF"/>
+                  <a:srgbClr val="0F172A"/>
                 </a:solidFill>
               </a:defRPr>
             </a:pPr>
@@ -7325,7 +7325,7 @@
             <a:pPr>
               <a:defRPr sz="1300">
                 <a:solidFill>
-                  <a:srgbClr val="94A3B8"/>
+                  <a:srgbClr val="334155"/>
                 </a:solidFill>
               </a:defRPr>
             </a:pPr>
@@ -7350,11 +7350,11 @@
             <a:avLst/>
           </a:prstGeom>
           <a:solidFill>
-            <a:srgbClr val="121826"/>
+            <a:srgbClr val="F8FAFC"/>
           </a:solidFill>
           <a:ln>
             <a:solidFill>
-              <a:srgbClr val="06B6D4"/>
+              <a:srgbClr val="0284C7"/>
             </a:solidFill>
           </a:ln>
         </p:spPr>
@@ -7405,7 +7405,7 @@
             <a:pPr>
               <a:defRPr sz="1100" b="1">
                 <a:solidFill>
-                  <a:srgbClr val="06B6D4"/>
+                  <a:srgbClr val="0284C7"/>
                 </a:solidFill>
               </a:defRPr>
             </a:pPr>
@@ -7417,7 +7417,7 @@
             <a:pPr>
               <a:defRPr sz="3600" b="1">
                 <a:solidFill>
-                  <a:srgbClr val="FFFFFF"/>
+                  <a:srgbClr val="0F172A"/>
                 </a:solidFill>
               </a:defRPr>
             </a:pPr>
@@ -7429,7 +7429,7 @@
             <a:pPr>
               <a:defRPr sz="1200">
                 <a:solidFill>
-                  <a:srgbClr val="94A3B8"/>
+                  <a:srgbClr val="334155"/>
                 </a:solidFill>
               </a:defRPr>
             </a:pPr>
@@ -7454,11 +7454,11 @@
             <a:avLst/>
           </a:prstGeom>
           <a:solidFill>
-            <a:srgbClr val="121826"/>
+            <a:srgbClr val="F8FAFC"/>
           </a:solidFill>
           <a:ln>
             <a:solidFill>
-              <a:srgbClr val="F59E0B"/>
+              <a:srgbClr val="D97706"/>
             </a:solidFill>
           </a:ln>
         </p:spPr>
@@ -7509,7 +7509,7 @@
             <a:pPr>
               <a:defRPr sz="1100" b="1">
                 <a:solidFill>
-                  <a:srgbClr val="F59E0B"/>
+                  <a:srgbClr val="D97706"/>
                 </a:solidFill>
               </a:defRPr>
             </a:pPr>
@@ -7521,7 +7521,7 @@
             <a:pPr>
               <a:defRPr sz="3600" b="1">
                 <a:solidFill>
-                  <a:srgbClr val="FFFFFF"/>
+                  <a:srgbClr val="0F172A"/>
                 </a:solidFill>
               </a:defRPr>
             </a:pPr>
@@ -7533,7 +7533,7 @@
             <a:pPr>
               <a:defRPr sz="1200">
                 <a:solidFill>
-                  <a:srgbClr val="94A3B8"/>
+                  <a:srgbClr val="334155"/>
                 </a:solidFill>
               </a:defRPr>
             </a:pPr>
@@ -7558,11 +7558,11 @@
             <a:avLst/>
           </a:prstGeom>
           <a:solidFill>
-            <a:srgbClr val="121826"/>
+            <a:srgbClr val="F8FAFC"/>
           </a:solidFill>
           <a:ln>
             <a:solidFill>
-              <a:srgbClr val="10B981"/>
+              <a:srgbClr val="059669"/>
             </a:solidFill>
           </a:ln>
         </p:spPr>
@@ -7613,7 +7613,7 @@
             <a:pPr>
               <a:defRPr sz="1100" b="1">
                 <a:solidFill>
-                  <a:srgbClr val="10B981"/>
+                  <a:srgbClr val="059669"/>
                 </a:solidFill>
               </a:defRPr>
             </a:pPr>
@@ -7625,7 +7625,7 @@
             <a:pPr>
               <a:defRPr sz="3600" b="1">
                 <a:solidFill>
-                  <a:srgbClr val="FFFFFF"/>
+                  <a:srgbClr val="0F172A"/>
                 </a:solidFill>
               </a:defRPr>
             </a:pPr>
@@ -7637,7 +7637,7 @@
             <a:pPr>
               <a:defRPr sz="1200">
                 <a:solidFill>
-                  <a:srgbClr val="94A3B8"/>
+                  <a:srgbClr val="334155"/>
                 </a:solidFill>
               </a:defRPr>
             </a:pPr>
@@ -7680,7 +7680,7 @@
             <a:avLst/>
           </a:prstGeom>
           <a:solidFill>
-            <a:srgbClr val="0B0F17"/>
+            <a:srgbClr val="FFFFFF"/>
           </a:solidFill>
           <a:ln>
             <a:noFill/>
@@ -7733,7 +7733,7 @@
             <a:pPr>
               <a:defRPr sz="1100" b="1">
                 <a:solidFill>
-                  <a:srgbClr val="10B981"/>
+                  <a:srgbClr val="059669"/>
                 </a:solidFill>
               </a:defRPr>
             </a:pPr>
@@ -7768,7 +7768,7 @@
             <a:pPr>
               <a:defRPr sz="2800" b="1">
                 <a:solidFill>
-                  <a:srgbClr val="FFFFFF"/>
+                  <a:srgbClr val="0F172A"/>
                 </a:solidFill>
               </a:defRPr>
             </a:pPr>
@@ -7803,7 +7803,7 @@
             <a:pPr>
               <a:defRPr sz="1300">
                 <a:solidFill>
-                  <a:srgbClr val="94A3B8"/>
+                  <a:srgbClr val="334155"/>
                 </a:solidFill>
               </a:defRPr>
             </a:pPr>
@@ -7828,11 +7828,11 @@
             <a:avLst/>
           </a:prstGeom>
           <a:solidFill>
-            <a:srgbClr val="121826"/>
+            <a:srgbClr val="F8FAFC"/>
           </a:solidFill>
           <a:ln>
             <a:solidFill>
-              <a:srgbClr val="F59E0B"/>
+              <a:srgbClr val="D97706"/>
             </a:solidFill>
           </a:ln>
         </p:spPr>
@@ -7883,7 +7883,7 @@
             <a:pPr>
               <a:defRPr sz="1400" b="1">
                 <a:solidFill>
-                  <a:srgbClr val="FFFFFF"/>
+                  <a:srgbClr val="0F172A"/>
                 </a:solidFill>
               </a:defRPr>
             </a:pPr>
@@ -7895,7 +7895,7 @@
             <a:pPr>
               <a:defRPr sz="1150">
                 <a:solidFill>
-                  <a:srgbClr val="94A3B8"/>
+                  <a:srgbClr val="334155"/>
                 </a:solidFill>
               </a:defRPr>
             </a:pPr>
@@ -7920,11 +7920,11 @@
             <a:avLst/>
           </a:prstGeom>
           <a:solidFill>
-            <a:srgbClr val="121826"/>
+            <a:srgbClr val="F8FAFC"/>
           </a:solidFill>
           <a:ln>
             <a:solidFill>
-              <a:srgbClr val="06B6D4"/>
+              <a:srgbClr val="0284C7"/>
             </a:solidFill>
           </a:ln>
         </p:spPr>
@@ -7975,7 +7975,7 @@
             <a:pPr>
               <a:defRPr sz="1400" b="1">
                 <a:solidFill>
-                  <a:srgbClr val="FFFFFF"/>
+                  <a:srgbClr val="0F172A"/>
                 </a:solidFill>
               </a:defRPr>
             </a:pPr>
@@ -7987,7 +7987,7 @@
             <a:pPr>
               <a:defRPr sz="1150">
                 <a:solidFill>
-                  <a:srgbClr val="94A3B8"/>
+                  <a:srgbClr val="334155"/>
                 </a:solidFill>
               </a:defRPr>
             </a:pPr>
@@ -8012,11 +8012,11 @@
             <a:avLst/>
           </a:prstGeom>
           <a:solidFill>
-            <a:srgbClr val="121826"/>
+            <a:srgbClr val="F8FAFC"/>
           </a:solidFill>
           <a:ln>
             <a:solidFill>
-              <a:srgbClr val="10B981"/>
+              <a:srgbClr val="059669"/>
             </a:solidFill>
           </a:ln>
         </p:spPr>
@@ -8067,7 +8067,7 @@
             <a:pPr>
               <a:defRPr sz="1400" b="1">
                 <a:solidFill>
-                  <a:srgbClr val="FFFFFF"/>
+                  <a:srgbClr val="0F172A"/>
                 </a:solidFill>
               </a:defRPr>
             </a:pPr>
@@ -8079,7 +8079,7 @@
             <a:pPr>
               <a:defRPr sz="1150">
                 <a:solidFill>
-                  <a:srgbClr val="94A3B8"/>
+                  <a:srgbClr val="334155"/>
                 </a:solidFill>
               </a:defRPr>
             </a:pPr>

</xml_diff>